<commit_message>
Professional UI, advanced tuning scripts, 85.61% results, fixed predict page
</commit_message>
<xml_diff>
--- a/Home_Price_Prediction_Presentation.pptx
+++ b/Home_Price_Prediction_Presentation.pptx
@@ -3349,7 +3349,7 @@
               </a:defRPr>
             </a:pPr>
             <a:r>
-              <a:t>• Feature Engineering: Add more derived features (price/sqft ratios)</a:t>
+              <a:t>• Feature Engineering: More geographic/neighborhood features</a:t>
             </a:r>
           </a:p>
           <a:p>
@@ -3365,7 +3365,7 @@
               </a:defRPr>
             </a:pPr>
             <a:r>
-              <a:t>• Ensemble Optimization: Tune voting/stacking weights</a:t>
+              <a:t>• Ensemble Optimization: Grid search over blend weights</a:t>
             </a:r>
           </a:p>
           <a:p>
@@ -3381,7 +3381,7 @@
               </a:defRPr>
             </a:pPr>
             <a:r>
-              <a:t>• Deep Learning: Explore neural networks for non-linear patterns</a:t>
+              <a:t>• Deep Learning: Neural networks for complex patterns</a:t>
             </a:r>
           </a:p>
           <a:p>
@@ -3397,7 +3397,7 @@
               </a:defRPr>
             </a:pPr>
             <a:r>
-              <a:t>• Time Series: Add temporal features for market trends</a:t>
+              <a:t>• CatBoost: Not tested yet - native categorical handling</a:t>
             </a:r>
           </a:p>
           <a:p>
@@ -3413,7 +3413,7 @@
               </a:defRPr>
             </a:pPr>
             <a:r>
-              <a:t>• External Data: Incorporate economic indicators, interest rates</a:t>
+              <a:t>• Time Series: Add temporal market trend features</a:t>
             </a:r>
           </a:p>
           <a:p>
@@ -3429,7 +3429,7 @@
               </a:defRPr>
             </a:pPr>
             <a:r>
-              <a:t>• Deployment: Scale web app for production use</a:t>
+              <a:t>• External Data: Economic indicators, interest rates, school ratings</a:t>
             </a:r>
           </a:p>
           <a:p>
@@ -3445,7 +3445,7 @@
               </a:defRPr>
             </a:pPr>
             <a:r>
-              <a:t>• Monitoring: Track model drift over time</a:t>
+              <a:t>• Target: Close the 2.79% gap to Steph's 88.4% baseline</a:t>
             </a:r>
           </a:p>
         </p:txBody>
@@ -3581,7 +3581,7 @@
               </a:defRPr>
             </a:pPr>
             <a:r>
-              <a:t>• Successfully achieved 89.7% R² on test set</a:t>
+              <a:t>• Achieved 85.61% R² on test set with Blend_XGB0.1_LGB0.9</a:t>
             </a:r>
           </a:p>
           <a:p>
@@ -3597,7 +3597,7 @@
               </a:defRPr>
             </a:pPr>
             <a:r>
-              <a:t>• Exceeded 85% target and beat Steph's 88.4% baseline</a:t>
+              <a:t>• Best result: Weighted Blend (10% XGBoost + 90% LightGBM)</a:t>
             </a:r>
           </a:p>
           <a:p>
@@ -3613,7 +3613,7 @@
               </a:defRPr>
             </a:pPr>
             <a:r>
-              <a:t>• RMSE of $172,978 - average prediction error</a:t>
+              <a:t>• RMSE of $321,335 - average prediction error</a:t>
             </a:r>
           </a:p>
           <a:p>
@@ -3629,7 +3629,7 @@
               </a:defRPr>
             </a:pPr>
             <a:r>
-              <a:t>• XGBoost with GPU tuning proved most effective</a:t>
+              <a:t>• Gap to Steph's 88.4%: 2.79 percentage points remaining</a:t>
             </a:r>
           </a:p>
           <a:p>
@@ -3645,7 +3645,7 @@
               </a:defRPr>
             </a:pPr>
             <a:r>
-              <a:t>• Clean, reproducible pipeline for future updates</a:t>
+              <a:t>• Clean, reproducible pipeline validated on Amarel HPC</a:t>
             </a:r>
           </a:p>
           <a:p>
@@ -3677,7 +3677,7 @@
               </a:defRPr>
             </a:pPr>
             <a:r>
-              <a:t>• Foundation for production real estate valuation system</a:t>
+              <a:t>• Strong foundation for continued improvement</a:t>
             </a:r>
           </a:p>
         </p:txBody>
@@ -3951,7 +3951,7 @@
               </a:defRPr>
             </a:pPr>
             <a:r>
-              <a:t>• Objective: Predict home prices with 85%+ accuracy (R² score)</a:t>
+              <a:t>• Objective: Predict home prices with high accuracy (targeting 88.4% R²)</a:t>
             </a:r>
           </a:p>
           <a:p>
@@ -3967,7 +3967,7 @@
               </a:defRPr>
             </a:pPr>
             <a:r>
-              <a:t>• Data: NJ MLS real estate transactions (January - August 2025)</a:t>
+              <a:t>• Data: Louisiana MLS real estate transactions (January - August 2025)</a:t>
             </a:r>
           </a:p>
           <a:p>
@@ -3983,7 +3983,7 @@
               </a:defRPr>
             </a:pPr>
             <a:r>
-              <a:t>• 72,611 total properties • 58,088 training • 14,523 testing</a:t>
+              <a:t>• 173,070 total properties • 150,311 training • 22,759 testing</a:t>
             </a:r>
           </a:p>
           <a:p>
@@ -3999,7 +3999,7 @@
               </a:defRPr>
             </a:pPr>
             <a:r>
-              <a:t>• 451 features including location, property details, and amenities</a:t>
+              <a:t>• 1,022 engineered features including location, property details, and amenities</a:t>
             </a:r>
           </a:p>
           <a:p>
@@ -4215,7 +4215,7 @@
               </a:defRPr>
             </a:pPr>
             <a:r>
-              <a:t>• Models Tested: Linear Regression, Ridge, Lasso, Random Forest</a:t>
+              <a:t>• Baseline Models: Linear Regression, Ridge, Lasso, Random Forest</a:t>
             </a:r>
           </a:p>
           <a:p>
@@ -4231,7 +4231,7 @@
               </a:defRPr>
             </a:pPr>
             <a:r>
-              <a:t>• Advanced Models: XGBoost, LightGBM, CatBoost, Neural Networks</a:t>
+              <a:t>• Advanced Models: XGBoost (GPU), LightGBM, CatBoost, Neural Networks</a:t>
             </a:r>
           </a:p>
           <a:p>
@@ -4360,7 +4360,7 @@
               </a:defRPr>
             </a:pPr>
             <a:r>
-              <a:t>XGBoost GPU-Accelerated Tuning</a:t>
+              <a:t>XGBoost &amp; LightGBM GPU-Accelerated Tuning</a:t>
             </a:r>
           </a:p>
         </p:txBody>
@@ -4399,7 +4399,7 @@
               </a:defRPr>
             </a:pPr>
             <a:r>
-              <a:t>• Stage 1: Broad search (20 iterations, CV=3) over wide parameter ranges</a:t>
+              <a:t>• XGBoost: 3-stage tuning (broad → refined → final training)</a:t>
             </a:r>
           </a:p>
           <a:p>
@@ -4415,7 +4415,7 @@
               </a:defRPr>
             </a:pPr>
             <a:r>
-              <a:t>• Stage 2: Refined search (25 iterations) around best parameters</a:t>
+              <a:t>• LightGBM: RandomizedSearchCV with 20 iterations, 3-fold CV</a:t>
             </a:r>
           </a:p>
           <a:p>
@@ -4431,7 +4431,7 @@
               </a:defRPr>
             </a:pPr>
             <a:r>
-              <a:t>• Stage 3: Final training with 2000 estimators + early stopping</a:t>
+              <a:t>• GPU Acceleration: device='cuda' for XGBoost on Amarel cluster</a:t>
             </a:r>
           </a:p>
           <a:p>
@@ -4447,7 +4447,7 @@
               </a:defRPr>
             </a:pPr>
             <a:r>
-              <a:t>• GPU Acceleration: device='cuda' for 10-15x speedup on Amarel cluster</a:t>
+              <a:t>• LightGBM: CPU mode with parallel processing (n_jobs=-1)</a:t>
             </a:r>
           </a:p>
           <a:p>
@@ -4463,7 +4463,7 @@
               </a:defRPr>
             </a:pPr>
             <a:r>
-              <a:t>• Key Parameters: learning_rate, max_depth, subsample, colsample_bytree</a:t>
+              <a:t>• Key Parameters: learning_rate, num_leaves, max_depth, colsample</a:t>
             </a:r>
           </a:p>
           <a:p>
@@ -4479,7 +4479,7 @@
               </a:defRPr>
             </a:pPr>
             <a:r>
-              <a:t>• Regularization: reg_alpha (L1), reg_lambda (L2), gamma (min split loss)</a:t>
+              <a:t>• Regularization: reg_alpha (L1), reg_lambda (L2) for both models</a:t>
             </a:r>
           </a:p>
           <a:p>
@@ -4673,7 +4673,7 @@
               </a:defRPr>
             </a:pPr>
             <a:r>
-              <a:t>89.7%</a:t>
+              <a:t>85.61%</a:t>
             </a:r>
           </a:p>
         </p:txBody>
@@ -4709,7 +4709,7 @@
               </a:defRPr>
             </a:pPr>
             <a:r>
-              <a:t>Test R² Score</a:t>
+              <a:t>Best R² Score</a:t>
             </a:r>
           </a:p>
         </p:txBody>
@@ -4790,7 +4790,7 @@
               </a:defRPr>
             </a:pPr>
             <a:r>
-              <a:t>$172,978</a:t>
+              <a:t>$321,335</a:t>
             </a:r>
           </a:p>
         </p:txBody>
@@ -4907,7 +4907,7 @@
               </a:defRPr>
             </a:pPr>
             <a:r>
-              <a:t>99.5%</a:t>
+              <a:t>Blend XGB0.1 LGB0.9</a:t>
             </a:r>
           </a:p>
         </p:txBody>
@@ -4943,7 +4943,7 @@
               </a:defRPr>
             </a:pPr>
             <a:r>
-              <a:t>Train R² Score</a:t>
+              <a:t>Best Model</a:t>
             </a:r>
           </a:p>
         </p:txBody>
@@ -5024,7 +5024,7 @@
               </a:defRPr>
             </a:pPr>
             <a:r>
-              <a:t>58,088</a:t>
+              <a:t>150,311</a:t>
             </a:r>
           </a:p>
         </p:txBody>
@@ -5141,7 +5141,7 @@
               </a:defRPr>
             </a:pPr>
             <a:r>
-              <a:t>14,523</a:t>
+              <a:t>22,759</a:t>
             </a:r>
           </a:p>
         </p:txBody>
@@ -5258,7 +5258,7 @@
               </a:defRPr>
             </a:pPr>
             <a:r>
-              <a:t>451</a:t>
+              <a:t>1,022</a:t>
             </a:r>
           </a:p>
         </p:txBody>
@@ -5430,7 +5430,7 @@
               </a:defRPr>
             </a:pPr>
             <a:r>
-              <a:t>• XGBoost (GPU-Tuned): 89.7% R² ✓ TARGET ACHIEVED</a:t>
+              <a:t>• Weighted Blend (10% XGB + 90% LGB): 85.61% R² ← BEST</a:t>
             </a:r>
           </a:p>
           <a:p>
@@ -5446,7 +5446,7 @@
               </a:defRPr>
             </a:pPr>
             <a:r>
-              <a:t>• Random Forest Baseline: 88.4% R² (Steph's benchmark)</a:t>
+              <a:t>• LightGBM (Tuned): 85.60% R²</a:t>
             </a:r>
           </a:p>
           <a:p>
@@ -5462,7 +5462,7 @@
               </a:defRPr>
             </a:pPr>
             <a:r>
-              <a:t>• Ridge Regression: 81.3% R²</a:t>
+              <a:t>• XGBoost (GPU-Tuned): 85.06% R²</a:t>
             </a:r>
           </a:p>
           <a:p>
@@ -5478,7 +5478,7 @@
               </a:defRPr>
             </a:pPr>
             <a:r>
-              <a:t>• Lasso Regression: 81.3% R²</a:t>
+              <a:t>• Stacking (XGB + LGB + Ridge meta): 83.95% R²</a:t>
             </a:r>
           </a:p>
           <a:p>
@@ -5494,7 +5494,7 @@
               </a:defRPr>
             </a:pPr>
             <a:r>
-              <a:t>• Linear Regression: 81.3% R²</a:t>
+              <a:t>• Voting (XGB + LGB average): 83.25% R²</a:t>
             </a:r>
           </a:p>
           <a:p>
@@ -5510,7 +5510,7 @@
               </a:defRPr>
             </a:pPr>
             <a:r>
-              <a:t>• Improvement over Linear: +8.4 percentage points</a:t>
+              <a:t>• Random Forest Baseline: 88.4% R² (Steph's benchmark)</a:t>
             </a:r>
           </a:p>
           <a:p>
@@ -5526,7 +5526,7 @@
               </a:defRPr>
             </a:pPr>
             <a:r>
-              <a:t>• Improvement over Steph: +1.3 percentage points</a:t>
+              <a:t>• Gap to Steph: -2.79 percentage points (room for improvement)</a:t>
             </a:r>
           </a:p>
         </p:txBody>
@@ -5694,7 +5694,7 @@
               </a:defRPr>
             </a:pPr>
             <a:r>
-              <a:t>• Geographic Location - City, County, Postal Code</a:t>
+              <a:t>• Geographic Location - City, MLSAreaMajor, Postal Code (target encoded)</a:t>
             </a:r>
           </a:p>
           <a:p>
@@ -5758,7 +5758,7 @@
               </a:defRPr>
             </a:pPr>
             <a:r>
-              <a:t>• School District - Major factor in home values</a:t>
+              <a:t>• Property Condition &amp; Quality - Assessor ratings</a:t>
             </a:r>
           </a:p>
         </p:txBody>
@@ -5894,7 +5894,7 @@
               </a:defRPr>
             </a:pPr>
             <a:r>
-              <a:t>• Python 3.10+ with scikit-learn, XGBoost, LightGBM, CatBoost</a:t>
+              <a:t>• Python 3.9+ with scikit-learn, XGBoost 2.1, LightGBM 3.3</a:t>
             </a:r>
           </a:p>
           <a:p>
@@ -5910,7 +5910,7 @@
               </a:defRPr>
             </a:pPr>
             <a:r>
-              <a:t>• GPU: NVIDIA CUDA via device='cuda' on Amarel cluster</a:t>
+              <a:t>• GPU: NVIDIA CUDA via device='cuda' on Amarel HPC cluster</a:t>
             </a:r>
           </a:p>
           <a:p>
@@ -5926,7 +5926,7 @@
               </a:defRPr>
             </a:pPr>
             <a:r>
-              <a:t>• Data Processing: pandas, numpy for 72K+ records</a:t>
+              <a:t>• Data Processing: pandas, numpy for 173K+ records × 1K features</a:t>
             </a:r>
           </a:p>
           <a:p>
@@ -5942,7 +5942,7 @@
               </a:defRPr>
             </a:pPr>
             <a:r>
-              <a:t>• Visualization: matplotlib, seaborn, plotly</a:t>
+              <a:t>• Feature Names: Sanitized for LightGBM JSON compatibility</a:t>
             </a:r>
           </a:p>
           <a:p>
@@ -5958,7 +5958,7 @@
               </a:defRPr>
             </a:pPr>
             <a:r>
-              <a:t>• Web App: Streamlit for interactive predictions</a:t>
+              <a:t>• Web App: Streamlit with plotly for interactive predictions</a:t>
             </a:r>
           </a:p>
           <a:p>
@@ -5990,7 +5990,7 @@
               </a:defRPr>
             </a:pPr>
             <a:r>
-              <a:t>• Version Control: Git for code management</a:t>
+              <a:t>• SLURM: Job submission for HPC GPU computing</a:t>
             </a:r>
           </a:p>
         </p:txBody>
@@ -6126,7 +6126,7 @@
               </a:defRPr>
             </a:pPr>
             <a:r>
-              <a:t>• Challenge: Large dataset (72K records × 451 features)</a:t>
+              <a:t>• Challenge: Large dataset (150K records × 1,022 features)</a:t>
             </a:r>
           </a:p>
           <a:p>
@@ -6142,7 +6142,7 @@
               </a:defRPr>
             </a:pPr>
             <a:r>
-              <a:t>• Solution: GPU acceleration + efficient data loading</a:t>
+              <a:t>• Solution: GPU acceleration + efficient memory management</a:t>
             </a:r>
           </a:p>
           <a:p>
@@ -6158,7 +6158,7 @@
               </a:defRPr>
             </a:pPr>
             <a:r>
-              <a:t>• Challenge: Data leakage from price-related features</a:t>
+              <a:t>• Challenge: Feature name compatibility (LightGBM JSON limits)</a:t>
             </a:r>
           </a:p>
           <a:p>
@@ -6174,7 +6174,7 @@
               </a:defRPr>
             </a:pPr>
             <a:r>
-              <a:t>• Solution: Careful feature removal (ListPrice, CloseDate)</a:t>
+              <a:t>• Solution: Sanitize names (replace commas, spaces with underscores)</a:t>
             </a:r>
           </a:p>
           <a:p>
@@ -6190,7 +6190,7 @@
               </a:defRPr>
             </a:pPr>
             <a:r>
-              <a:t>• Challenge: Hyperparameter space too large</a:t>
+              <a:t>• Challenge: LightGBM GPU build not available on cluster</a:t>
             </a:r>
           </a:p>
           <a:p>
@@ -6206,7 +6206,7 @@
               </a:defRPr>
             </a:pPr>
             <a:r>
-              <a:t>• Solution: 3-stage tuning (broad → refined → final)</a:t>
+              <a:t>• Solution: Use CPU mode with n_jobs=-1 (still fast: 21s training)</a:t>
             </a:r>
           </a:p>
           <a:p>
@@ -6222,7 +6222,7 @@
               </a:defRPr>
             </a:pPr>
             <a:r>
-              <a:t>• Challenge: Model overfitting (99.5% train R²)</a:t>
+              <a:t>• Challenge: Gap to Steph's 88.4% baseline</a:t>
             </a:r>
           </a:p>
           <a:p>
@@ -6238,7 +6238,7 @@
               </a:defRPr>
             </a:pPr>
             <a:r>
-              <a:t>• Solution: Early stopping + regularization</a:t>
+              <a:t>• Solution: Ensemble blending brought us from 84.68% to 85.61%</a:t>
             </a:r>
           </a:p>
         </p:txBody>

</xml_diff>